<commit_message>
Harden multi-theme readability and validation
</commit_message>
<xml_diff>
--- a/docs/theme-preview/pptx/bentogrid.pptx
+++ b/docs/theme-preview/pptx/bentogrid.pptx
@@ -8800,280 +8800,16 @@
           </a:ln>
         </p:spPr>
       </p:sp>
-      <p:pic>
-        <p:nvPicPr>
-          <p:cNvPr id="37" name="Image 0" descr="preencoded.png">    </p:cNvPr>
-          <p:cNvPicPr>
-            <a:picLocks noChangeAspect="1"/>
-          </p:cNvPicPr>
-          <p:nvPr/>
-        </p:nvPicPr>
-        <p:blipFill>
-          <a:blip r:embed="rId1">
-            <a:extLst>
-              <a:ext uri="{96DAC541-7B7A-43D3-8B79-37D633B846F1}">
-                <asvg:svgBlip xmlns:asvg="http://schemas.microsoft.com/office/drawing/2016/SVG/main" r:embed="rId2"/>
-              </a:ext>
-            </a:extLst>
-          </a:blip>
-          <a:stretch>
-            <a:fillRect/>
-          </a:stretch>
-        </p:blipFill>
-        <p:spPr>
-          <a:xfrm>
-            <a:off x="822960" y="1463040"/>
-            <a:ext cx="5029200" cy="1920240"/>
-          </a:xfrm>
-          <a:prstGeom prst="rect">
-            <a:avLst/>
-          </a:prstGeom>
-        </p:spPr>
-      </p:pic>
-      <p:sp>
-        <p:nvSpPr>
-          <p:cNvPr id="38" name="Shape 35"/>
-          <p:cNvSpPr/>
-          <p:nvPr/>
-        </p:nvSpPr>
-        <p:spPr>
-          <a:xfrm>
-            <a:off x="822960" y="1463040"/>
-            <a:ext cx="5029200" cy="1920240"/>
-          </a:xfrm>
-          <a:prstGeom prst="rect">
-            <a:avLst/>
-          </a:prstGeom>
-          <a:solidFill>
-            <a:srgbClr val="FFFFFF">
-              <a:alpha val="0"/>
-            </a:srgbClr>
-          </a:solidFill>
-          <a:ln w="12700">
-            <a:solidFill>
-              <a:srgbClr val="CBD5E1">
-                <a:alpha val="0"/>
-              </a:srgbClr>
-            </a:solidFill>
-            <a:prstDash val="solid"/>
-          </a:ln>
-          <a:effectLst>
-            <a:outerShdw sx="100000" sy="100000" kx="0" ky="0" algn="bl" rotWithShape="0" blurRad="12700" dist="50800" dir="2700000">
-              <a:srgbClr val="000000">
-                <a:alpha val="8000"/>
-              </a:srgbClr>
-            </a:outerShdw>
-          </a:effectLst>
-        </p:spPr>
-      </p:sp>
-      <p:pic>
-        <p:nvPicPr>
-          <p:cNvPr id="39" name="Image 1" descr="preencoded.png">    </p:cNvPr>
-          <p:cNvPicPr>
-            <a:picLocks noChangeAspect="1"/>
-          </p:cNvPicPr>
-          <p:nvPr/>
-        </p:nvPicPr>
-        <p:blipFill>
-          <a:blip r:embed="rId3">
-            <a:extLst>
-              <a:ext uri="{96DAC541-7B7A-43D3-8B79-37D633B846F1}">
-                <asvg:svgBlip xmlns:asvg="http://schemas.microsoft.com/office/drawing/2016/SVG/main" r:embed="rId4"/>
-              </a:ext>
-            </a:extLst>
-          </a:blip>
-          <a:stretch>
-            <a:fillRect/>
-          </a:stretch>
-        </p:blipFill>
-        <p:spPr>
-          <a:xfrm>
-            <a:off x="6309360" y="1463040"/>
-            <a:ext cx="5029200" cy="1920240"/>
-          </a:xfrm>
-          <a:prstGeom prst="rect">
-            <a:avLst/>
-          </a:prstGeom>
-        </p:spPr>
-      </p:pic>
-      <p:sp>
-        <p:nvSpPr>
-          <p:cNvPr id="40" name="Shape 36"/>
-          <p:cNvSpPr/>
-          <p:nvPr/>
-        </p:nvSpPr>
-        <p:spPr>
-          <a:xfrm>
-            <a:off x="6309360" y="1463040"/>
-            <a:ext cx="5029200" cy="1920240"/>
-          </a:xfrm>
-          <a:prstGeom prst="rect">
-            <a:avLst/>
-          </a:prstGeom>
-          <a:solidFill>
-            <a:srgbClr val="FFFFFF">
-              <a:alpha val="0"/>
-            </a:srgbClr>
-          </a:solidFill>
-          <a:ln w="12700">
-            <a:solidFill>
-              <a:srgbClr val="CBD5E1">
-                <a:alpha val="0"/>
-              </a:srgbClr>
-            </a:solidFill>
-            <a:prstDash val="solid"/>
-          </a:ln>
-          <a:effectLst>
-            <a:outerShdw sx="100000" sy="100000" kx="0" ky="0" algn="bl" rotWithShape="0" blurRad="12700" dist="50800" dir="2700000">
-              <a:srgbClr val="000000">
-                <a:alpha val="8000"/>
-              </a:srgbClr>
-            </a:outerShdw>
-          </a:effectLst>
-        </p:spPr>
-      </p:sp>
-      <p:pic>
-        <p:nvPicPr>
-          <p:cNvPr id="41" name="Image 2" descr="preencoded.png">    </p:cNvPr>
-          <p:cNvPicPr>
-            <a:picLocks noChangeAspect="1"/>
-          </p:cNvPicPr>
-          <p:nvPr/>
-        </p:nvPicPr>
-        <p:blipFill>
-          <a:blip r:embed="rId5">
-            <a:extLst>
-              <a:ext uri="{96DAC541-7B7A-43D3-8B79-37D633B846F1}">
-                <asvg:svgBlip xmlns:asvg="http://schemas.microsoft.com/office/drawing/2016/SVG/main" r:embed="rId6"/>
-              </a:ext>
-            </a:extLst>
-          </a:blip>
-          <a:stretch>
-            <a:fillRect/>
-          </a:stretch>
-        </p:blipFill>
-        <p:spPr>
-          <a:xfrm>
-            <a:off x="822960" y="3749040"/>
-            <a:ext cx="5029200" cy="1920240"/>
-          </a:xfrm>
-          <a:prstGeom prst="rect">
-            <a:avLst/>
-          </a:prstGeom>
-        </p:spPr>
-      </p:pic>
-      <p:sp>
-        <p:nvSpPr>
-          <p:cNvPr id="42" name="Shape 37"/>
-          <p:cNvSpPr/>
-          <p:nvPr/>
-        </p:nvSpPr>
-        <p:spPr>
-          <a:xfrm>
-            <a:off x="822960" y="3749040"/>
-            <a:ext cx="5029200" cy="1920240"/>
-          </a:xfrm>
-          <a:prstGeom prst="rect">
-            <a:avLst/>
-          </a:prstGeom>
-          <a:solidFill>
-            <a:srgbClr val="FFFFFF">
-              <a:alpha val="0"/>
-            </a:srgbClr>
-          </a:solidFill>
-          <a:ln w="12700">
-            <a:solidFill>
-              <a:srgbClr val="CBD5E1">
-                <a:alpha val="0"/>
-              </a:srgbClr>
-            </a:solidFill>
-            <a:prstDash val="solid"/>
-          </a:ln>
-          <a:effectLst>
-            <a:outerShdw sx="100000" sy="100000" kx="0" ky="0" algn="bl" rotWithShape="0" blurRad="12700" dist="50800" dir="2700000">
-              <a:srgbClr val="000000">
-                <a:alpha val="8000"/>
-              </a:srgbClr>
-            </a:outerShdw>
-          </a:effectLst>
-        </p:spPr>
-      </p:sp>
-      <p:pic>
-        <p:nvPicPr>
-          <p:cNvPr id="43" name="Image 3" descr="preencoded.png">    </p:cNvPr>
-          <p:cNvPicPr>
-            <a:picLocks noChangeAspect="1"/>
-          </p:cNvPicPr>
-          <p:nvPr/>
-        </p:nvPicPr>
-        <p:blipFill>
-          <a:blip r:embed="rId7">
-            <a:extLst>
-              <a:ext uri="{96DAC541-7B7A-43D3-8B79-37D633B846F1}">
-                <asvg:svgBlip xmlns:asvg="http://schemas.microsoft.com/office/drawing/2016/SVG/main" r:embed="rId8"/>
-              </a:ext>
-            </a:extLst>
-          </a:blip>
-          <a:stretch>
-            <a:fillRect/>
-          </a:stretch>
-        </p:blipFill>
-        <p:spPr>
-          <a:xfrm>
-            <a:off x="6309360" y="3749040"/>
-            <a:ext cx="5029200" cy="1920240"/>
-          </a:xfrm>
-          <a:prstGeom prst="rect">
-            <a:avLst/>
-          </a:prstGeom>
-        </p:spPr>
-      </p:pic>
-      <p:sp>
-        <p:nvSpPr>
-          <p:cNvPr id="44" name="Shape 38"/>
-          <p:cNvSpPr/>
-          <p:nvPr/>
-        </p:nvSpPr>
-        <p:spPr>
-          <a:xfrm>
-            <a:off x="6309360" y="3749040"/>
-            <a:ext cx="5029200" cy="1920240"/>
-          </a:xfrm>
-          <a:prstGeom prst="rect">
-            <a:avLst/>
-          </a:prstGeom>
-          <a:solidFill>
-            <a:srgbClr val="FFFFFF">
-              <a:alpha val="0"/>
-            </a:srgbClr>
-          </a:solidFill>
-          <a:ln w="12700">
-            <a:solidFill>
-              <a:srgbClr val="CBD5E1">
-                <a:alpha val="0"/>
-              </a:srgbClr>
-            </a:solidFill>
-            <a:prstDash val="solid"/>
-          </a:ln>
-          <a:effectLst>
-            <a:outerShdw sx="100000" sy="100000" kx="0" ky="0" algn="bl" rotWithShape="0" blurRad="12700" dist="50800" dir="2700000">
-              <a:srgbClr val="000000">
-                <a:alpha val="8000"/>
-              </a:srgbClr>
-            </a:outerShdw>
-          </a:effectLst>
-        </p:spPr>
-      </p:sp>
-      <p:sp>
-        <p:nvSpPr>
-          <p:cNvPr id="45" name="Shape 39"/>
-          <p:cNvSpPr/>
-          <p:nvPr/>
-        </p:nvSpPr>
-        <p:spPr>
-          <a:xfrm>
-            <a:off x="822960" y="1463040"/>
-            <a:ext cx="73152" cy="1920240"/>
+      <p:sp>
+        <p:nvSpPr>
+          <p:cNvPr id="37" name="Shape 35"/>
+          <p:cNvSpPr/>
+          <p:nvPr/>
+        </p:nvSpPr>
+        <p:spPr>
+          <a:xfrm>
+            <a:off x="822960" y="1389888"/>
+            <a:ext cx="4937760" cy="73152"/>
           </a:xfrm>
           <a:prstGeom prst="rect">
             <a:avLst/>
@@ -9093,41 +8829,14 @@
       </p:sp>
       <p:sp>
         <p:nvSpPr>
-          <p:cNvPr id="46" name="Shape 40"/>
-          <p:cNvSpPr/>
-          <p:nvPr/>
-        </p:nvSpPr>
-        <p:spPr>
-          <a:xfrm>
-            <a:off x="6309360" y="1463040"/>
-            <a:ext cx="73152" cy="1920240"/>
-          </a:xfrm>
-          <a:prstGeom prst="rect">
-            <a:avLst/>
-          </a:prstGeom>
-          <a:solidFill>
-            <a:srgbClr val="F0AA11"/>
-          </a:solidFill>
-          <a:ln w="12700">
-            <a:solidFill>
-              <a:srgbClr val="F0AA11">
-                <a:alpha val="0"/>
-              </a:srgbClr>
-            </a:solidFill>
-            <a:prstDash val="solid"/>
-          </a:ln>
-        </p:spPr>
-      </p:sp>
-      <p:sp>
-        <p:nvSpPr>
-          <p:cNvPr id="47" name="Shape 41"/>
-          <p:cNvSpPr/>
-          <p:nvPr/>
-        </p:nvSpPr>
-        <p:spPr>
-          <a:xfrm>
-            <a:off x="822960" y="3749040"/>
-            <a:ext cx="73152" cy="1920240"/>
+          <p:cNvPr id="38" name="Shape 36"/>
+          <p:cNvSpPr/>
+          <p:nvPr/>
+        </p:nvSpPr>
+        <p:spPr>
+          <a:xfrm>
+            <a:off x="6400800" y="1389888"/>
+            <a:ext cx="4937760" cy="73152"/>
           </a:xfrm>
           <a:prstGeom prst="rect">
             <a:avLst/>
@@ -9147,34 +8856,7 @@
       </p:sp>
       <p:sp>
         <p:nvSpPr>
-          <p:cNvPr id="48" name="Shape 42"/>
-          <p:cNvSpPr/>
-          <p:nvPr/>
-        </p:nvSpPr>
-        <p:spPr>
-          <a:xfrm>
-            <a:off x="6309360" y="3749040"/>
-            <a:ext cx="73152" cy="1920240"/>
-          </a:xfrm>
-          <a:prstGeom prst="rect">
-            <a:avLst/>
-          </a:prstGeom>
-          <a:solidFill>
-            <a:srgbClr val="F0AA11"/>
-          </a:solidFill>
-          <a:ln w="12700">
-            <a:solidFill>
-              <a:srgbClr val="F0AA11">
-                <a:alpha val="0"/>
-              </a:srgbClr>
-            </a:solidFill>
-            <a:prstDash val="solid"/>
-          </a:ln>
-        </p:spPr>
-      </p:sp>
-      <p:sp>
-        <p:nvSpPr>
-          <p:cNvPr id="49" name="mdpr:1-2-e3669a:title:__title:1-2-e3669a"/>
+          <p:cNvPr id="39" name="mdpr:1-2-e3669a:title:__title:1-2-e3669a"/>
           <p:cNvSpPr txBox="1"/>
           <p:nvPr/>
         </p:nvSpPr>
@@ -9216,80 +8898,23 @@
       </p:sp>
       <p:sp>
         <p:nvSpPr>
-          <p:cNvPr id="50" name="Shape 44"/>
-          <p:cNvSpPr/>
-          <p:nvPr/>
-        </p:nvSpPr>
-        <p:spPr>
-          <a:xfrm>
-            <a:off x="976122" y="2130552"/>
-            <a:ext cx="585216" cy="585216"/>
-          </a:xfrm>
-          <a:prstGeom prst="roundRect">
-            <a:avLst>
-              <a:gd name="adj" fmla="val 6250"/>
-            </a:avLst>
-          </a:prstGeom>
-          <a:solidFill>
-            <a:srgbClr val="F8FAFC"/>
-          </a:solidFill>
-          <a:ln w="12700">
-            <a:solidFill>
-              <a:srgbClr val="CBD5E1"/>
-            </a:solidFill>
-            <a:prstDash val="solid"/>
-          </a:ln>
-        </p:spPr>
-      </p:sp>
-      <p:pic>
-        <p:nvPicPr>
-          <p:cNvPr id="51" name="Image 4" descr="article icon from tabler-icons (MIT)">    </p:cNvPr>
-          <p:cNvPicPr>
-            <a:picLocks noChangeAspect="1"/>
-          </p:cNvPicPr>
-          <p:nvPr/>
-        </p:nvPicPr>
-        <p:blipFill>
-          <a:blip r:embed="rId9">
-            <a:extLst>
-              <a:ext uri="{96DAC541-7B7A-43D3-8B79-37D633B846F1}">
-                <asvg:svgBlip xmlns:asvg="http://schemas.microsoft.com/office/drawing/2016/SVG/main" r:embed="rId10"/>
-              </a:ext>
-            </a:extLst>
-          </a:blip>
-          <a:stretch>
-            <a:fillRect/>
-          </a:stretch>
-        </p:blipFill>
-        <p:spPr>
-          <a:xfrm>
-            <a:off x="1049274" y="2203704"/>
-            <a:ext cx="438912" cy="438912"/>
+          <p:cNvPr id="40" name="mdpr:1-2-e3669a:left:block-15-chunk-1-block-15-chunk-1"/>
+          <p:cNvSpPr txBox="1"/>
+          <p:nvPr/>
+        </p:nvSpPr>
+        <p:spPr>
+          <a:xfrm>
+            <a:off x="896112" y="1499616"/>
+            <a:ext cx="4791456" cy="4398264"/>
           </a:xfrm>
           <a:prstGeom prst="rect">
             <a:avLst/>
           </a:prstGeom>
-        </p:spPr>
-      </p:pic>
-      <p:sp>
-        <p:nvSpPr>
-          <p:cNvPr id="52" name="mdpr:1-2-e3669a:item-1:block-15-chunk-1"/>
-          <p:cNvSpPr txBox="1"/>
-          <p:nvPr/>
-        </p:nvSpPr>
-        <p:spPr>
-          <a:xfrm>
-            <a:off x="1689354" y="1627632"/>
-            <a:ext cx="3961638" cy="1591056"/>
-          </a:xfrm>
-          <a:prstGeom prst="rect">
-            <a:avLst/>
-          </a:prstGeom>
           <a:noFill/>
           <a:ln/>
         </p:spPr>
         <p:txBody>
-          <a:bodyPr wrap="square" lIns="0" tIns="25400" rIns="25400" bIns="0" rtlCol="0" anchor="ctr"/>
+          <a:bodyPr wrap="square" lIns="0" tIns="25400" rIns="25400" bIns="0" rtlCol="0" anchor="t"/>
           <a:lstStyle/>
           <a:p>
             <a:pPr algn="l" indent="0" marL="0">
@@ -9299,7 +8924,7 @@
               <a:buNone/>
             </a:pPr>
             <a:r>
-              <a:rPr lang="en-US" sz="2200" b="1" dirty="0">
+              <a:rPr lang="en-US" sz="1800" b="1" dirty="0">
                 <a:solidFill>
                   <a:srgbClr val="0F766E"/>
                 </a:solidFill>
@@ -9307,7 +8932,7 @@
                 <a:ea typeface="Pretendard" pitchFamily="34" charset="-122"/>
                 <a:cs typeface="Pretendard" pitchFamily="34" charset="-120"/>
               </a:rPr>
-              <a:t>Surfaces</a:t>
+              <a:t>- Surfaces</a:t>
             </a:r>
             <a:pPr algn="l" indent="0" marL="0">
               <a:lnSpc>
@@ -9316,7 +8941,7 @@
               <a:buNone/>
             </a:pPr>
             <a:r>
-              <a:rPr lang="en-US" sz="2200" dirty="0">
+              <a:rPr lang="en-US" sz="1800" dirty="0">
                 <a:solidFill>
                   <a:srgbClr val="111111"/>
                 </a:solidFill>
@@ -9326,86 +8951,69 @@
               </a:rPr>
               <a:t>  rounded-card, two-corner-card, flag-drop, ticket-panel, notched-panel, circle-vine.</a:t>
             </a:r>
-            <a:endParaRPr lang="en-US" sz="2200" dirty="0"/>
+            <a:endParaRPr lang="en-US" sz="1800" dirty="0"/>
+          </a:p>
+          <a:p>
+            <a:pPr algn="l" indent="0" marL="0">
+              <a:lnSpc>
+                <a:spcPct val="120000"/>
+              </a:lnSpc>
+              <a:buNone/>
+            </a:pPr>
+            <a:r>
+              <a:rPr lang="en-US" sz="1800" b="1" dirty="0">
+                <a:solidFill>
+                  <a:srgbClr val="0F766E"/>
+                </a:solidFill>
+                <a:latin typeface="Pretendard" pitchFamily="34" charset="0"/>
+                <a:ea typeface="Pretendard" pitchFamily="34" charset="-122"/>
+                <a:cs typeface="Pretendard" pitchFamily="34" charset="-120"/>
+              </a:rPr>
+              <a:t>- Layouts</a:t>
+            </a:r>
+            <a:endParaRPr lang="en-US" sz="1800" dirty="0"/>
+          </a:p>
+          <a:p>
+            <a:pPr algn="l" indent="0" marL="0">
+              <a:lnSpc>
+                <a:spcPct val="120000"/>
+              </a:lnSpc>
+              <a:buNone/>
+            </a:pPr>
+            <a:r>
+              <a:rPr lang="en-US" sz="1800" dirty="0">
+                <a:solidFill>
+                  <a:srgbClr val="111111"/>
+                </a:solidFill>
+                <a:latin typeface="Pretendard" pitchFamily="34" charset="0"/>
+                <a:ea typeface="Pretendard" pitchFamily="34" charset="-122"/>
+                <a:cs typeface="Pretendard" pitchFamily="34" charset="-120"/>
+              </a:rPr>
+              <a:t>  toc-strips, two-column-compare, three-card-grid, six-tile-grid, timeline-rail, pipeline-chain.</a:t>
+            </a:r>
+            <a:endParaRPr lang="en-US" sz="1800" dirty="0"/>
           </a:p>
         </p:txBody>
       </p:sp>
       <p:sp>
         <p:nvSpPr>
-          <p:cNvPr id="53" name="Shape 46"/>
-          <p:cNvSpPr/>
-          <p:nvPr/>
-        </p:nvSpPr>
-        <p:spPr>
-          <a:xfrm>
-            <a:off x="6462522" y="2130552"/>
-            <a:ext cx="585216" cy="585216"/>
-          </a:xfrm>
-          <a:prstGeom prst="roundRect">
-            <a:avLst>
-              <a:gd name="adj" fmla="val 6250"/>
-            </a:avLst>
-          </a:prstGeom>
-          <a:solidFill>
-            <a:srgbClr val="F8FAFC"/>
-          </a:solidFill>
-          <a:ln w="12700">
-            <a:solidFill>
-              <a:srgbClr val="CBD5E1"/>
-            </a:solidFill>
-            <a:prstDash val="solid"/>
-          </a:ln>
-        </p:spPr>
-      </p:sp>
-      <p:pic>
-        <p:nvPicPr>
-          <p:cNvPr id="54" name="Image 5" descr="table icon from tabler-icons (MIT)">    </p:cNvPr>
-          <p:cNvPicPr>
-            <a:picLocks noChangeAspect="1"/>
-          </p:cNvPicPr>
-          <p:nvPr/>
-        </p:nvPicPr>
-        <p:blipFill>
-          <a:blip r:embed="rId11">
-            <a:extLst>
-              <a:ext uri="{96DAC541-7B7A-43D3-8B79-37D633B846F1}">
-                <asvg:svgBlip xmlns:asvg="http://schemas.microsoft.com/office/drawing/2016/SVG/main" r:embed="rId12"/>
-              </a:ext>
-            </a:extLst>
-          </a:blip>
-          <a:stretch>
-            <a:fillRect/>
-          </a:stretch>
-        </p:blipFill>
-        <p:spPr>
-          <a:xfrm>
-            <a:off x="6535674" y="2203704"/>
-            <a:ext cx="438912" cy="438912"/>
+          <p:cNvPr id="41" name="mdpr:1-2-e3669a:right:block-15-chunk-1-block-15-chunk-1"/>
+          <p:cNvSpPr txBox="1"/>
+          <p:nvPr/>
+        </p:nvSpPr>
+        <p:spPr>
+          <a:xfrm>
+            <a:off x="6473952" y="1499616"/>
+            <a:ext cx="4791456" cy="4398264"/>
           </a:xfrm>
           <a:prstGeom prst="rect">
             <a:avLst/>
           </a:prstGeom>
-        </p:spPr>
-      </p:pic>
-      <p:sp>
-        <p:nvSpPr>
-          <p:cNvPr id="55" name="mdpr:1-2-e3669a:item-2:block-15-chunk-1"/>
-          <p:cNvSpPr txBox="1"/>
-          <p:nvPr/>
-        </p:nvSpPr>
-        <p:spPr>
-          <a:xfrm>
-            <a:off x="7175754" y="1627632"/>
-            <a:ext cx="3961638" cy="1591056"/>
-          </a:xfrm>
-          <a:prstGeom prst="rect">
-            <a:avLst/>
-          </a:prstGeom>
           <a:noFill/>
           <a:ln/>
         </p:spPr>
         <p:txBody>
-          <a:bodyPr wrap="square" lIns="0" tIns="25400" rIns="25400" bIns="0" rtlCol="0" anchor="ctr"/>
+          <a:bodyPr wrap="square" lIns="0" tIns="25400" rIns="25400" bIns="0" rtlCol="0" anchor="t"/>
           <a:lstStyle/>
           <a:p>
             <a:pPr algn="l" indent="0" marL="0">
@@ -9415,7 +9023,7 @@
               <a:buNone/>
             </a:pPr>
             <a:r>
-              <a:rPr lang="en-US" sz="2200" b="1" dirty="0">
+              <a:rPr lang="en-US" sz="1800" b="1" dirty="0">
                 <a:solidFill>
                   <a:srgbClr val="0F766E"/>
                 </a:solidFill>
@@ -9423,7 +9031,7 @@
                 <a:ea typeface="Pretendard" pitchFamily="34" charset="-122"/>
                 <a:cs typeface="Pretendard" pitchFamily="34" charset="-120"/>
               </a:rPr>
-              <a:t>Layouts</a:t>
+              <a:t>- Evidence</a:t>
             </a:r>
             <a:pPr algn="l" indent="0" marL="0">
               <a:lnSpc>
@@ -9432,123 +9040,7 @@
               <a:buNone/>
             </a:pPr>
             <a:r>
-              <a:rPr lang="en-US" sz="2200" dirty="0">
-                <a:solidFill>
-                  <a:srgbClr val="111111"/>
-                </a:solidFill>
-                <a:latin typeface="Pretendard" pitchFamily="34" charset="0"/>
-                <a:ea typeface="Pretendard" pitchFamily="34" charset="-122"/>
-                <a:cs typeface="Pretendard" pitchFamily="34" charset="-120"/>
-              </a:rPr>
-              <a:t>  toc-strips, two-column-compare, three-card-grid, six-tile-grid, timeline-rail, pipeline-chain.</a:t>
-            </a:r>
-            <a:endParaRPr lang="en-US" sz="2200" dirty="0"/>
-          </a:p>
-        </p:txBody>
-      </p:sp>
-      <p:sp>
-        <p:nvSpPr>
-          <p:cNvPr id="56" name="Shape 48"/>
-          <p:cNvSpPr/>
-          <p:nvPr/>
-        </p:nvSpPr>
-        <p:spPr>
-          <a:xfrm>
-            <a:off x="976122" y="4416552"/>
-            <a:ext cx="585216" cy="585216"/>
-          </a:xfrm>
-          <a:prstGeom prst="roundRect">
-            <a:avLst>
-              <a:gd name="adj" fmla="val 6250"/>
-            </a:avLst>
-          </a:prstGeom>
-          <a:solidFill>
-            <a:srgbClr val="F8FAFC"/>
-          </a:solidFill>
-          <a:ln w="12700">
-            <a:solidFill>
-              <a:srgbClr val="CBD5E1"/>
-            </a:solidFill>
-            <a:prstDash val="solid"/>
-          </a:ln>
-        </p:spPr>
-      </p:sp>
-      <p:pic>
-        <p:nvPicPr>
-          <p:cNvPr id="57" name="Image 6" descr="chart icon from tabler-icons (MIT)">    </p:cNvPr>
-          <p:cNvPicPr>
-            <a:picLocks noChangeAspect="1"/>
-          </p:cNvPicPr>
-          <p:nvPr/>
-        </p:nvPicPr>
-        <p:blipFill>
-          <a:blip r:embed="rId13">
-            <a:extLst>
-              <a:ext uri="{96DAC541-7B7A-43D3-8B79-37D633B846F1}">
-                <asvg:svgBlip xmlns:asvg="http://schemas.microsoft.com/office/drawing/2016/SVG/main" r:embed="rId14"/>
-              </a:ext>
-            </a:extLst>
-          </a:blip>
-          <a:stretch>
-            <a:fillRect/>
-          </a:stretch>
-        </p:blipFill>
-        <p:spPr>
-          <a:xfrm>
-            <a:off x="1049274" y="4489704"/>
-            <a:ext cx="438912" cy="438912"/>
-          </a:xfrm>
-          <a:prstGeom prst="rect">
-            <a:avLst/>
-          </a:prstGeom>
-        </p:spPr>
-      </p:pic>
-      <p:sp>
-        <p:nvSpPr>
-          <p:cNvPr id="58" name="mdpr:1-2-e3669a:item-3:block-15-chunk-1"/>
-          <p:cNvSpPr txBox="1"/>
-          <p:nvPr/>
-        </p:nvSpPr>
-        <p:spPr>
-          <a:xfrm>
-            <a:off x="1689354" y="3913632"/>
-            <a:ext cx="3961638" cy="1591056"/>
-          </a:xfrm>
-          <a:prstGeom prst="rect">
-            <a:avLst/>
-          </a:prstGeom>
-          <a:noFill/>
-          <a:ln/>
-        </p:spPr>
-        <p:txBody>
-          <a:bodyPr wrap="square" lIns="0" tIns="25400" rIns="25400" bIns="0" rtlCol="0" anchor="ctr"/>
-          <a:lstStyle/>
-          <a:p>
-            <a:pPr algn="l" indent="0" marL="0">
-              <a:lnSpc>
-                <a:spcPct val="120000"/>
-              </a:lnSpc>
-              <a:buNone/>
-            </a:pPr>
-            <a:r>
-              <a:rPr lang="en-US" sz="2200" b="1" dirty="0">
-                <a:solidFill>
-                  <a:srgbClr val="0F766E"/>
-                </a:solidFill>
-                <a:latin typeface="Pretendard" pitchFamily="34" charset="0"/>
-                <a:ea typeface="Pretendard" pitchFamily="34" charset="-122"/>
-                <a:cs typeface="Pretendard" pitchFamily="34" charset="-120"/>
-              </a:rPr>
-              <a:t>Evidence</a:t>
-            </a:r>
-            <a:pPr algn="l" indent="0" marL="0">
-              <a:lnSpc>
-                <a:spcPct val="120000"/>
-              </a:lnSpc>
-              <a:buNone/>
-            </a:pPr>
-            <a:r>
-              <a:rPr lang="en-US" sz="2200" dirty="0">
+              <a:rPr lang="en-US" sz="1800" dirty="0">
                 <a:solidFill>
                   <a:srgbClr val="111111"/>
                 </a:solidFill>
@@ -9558,87 +9050,8 @@
               </a:rPr>
               <a:t>  chart-table-pair, metric-proof, arc-ring-proof, gauge-proof, connected-strip, mixed-object-pack.</a:t>
             </a:r>
-            <a:endParaRPr lang="en-US" sz="2200" dirty="0"/>
+            <a:endParaRPr lang="en-US" sz="1800" dirty="0"/>
           </a:p>
-        </p:txBody>
-      </p:sp>
-      <p:sp>
-        <p:nvSpPr>
-          <p:cNvPr id="59" name="Shape 50"/>
-          <p:cNvSpPr/>
-          <p:nvPr/>
-        </p:nvSpPr>
-        <p:spPr>
-          <a:xfrm>
-            <a:off x="6462522" y="4416552"/>
-            <a:ext cx="585216" cy="585216"/>
-          </a:xfrm>
-          <a:prstGeom prst="roundRect">
-            <a:avLst>
-              <a:gd name="adj" fmla="val 6250"/>
-            </a:avLst>
-          </a:prstGeom>
-          <a:solidFill>
-            <a:srgbClr val="F8FAFC"/>
-          </a:solidFill>
-          <a:ln w="12700">
-            <a:solidFill>
-              <a:srgbClr val="CBD5E1"/>
-            </a:solidFill>
-            <a:prstDash val="solid"/>
-          </a:ln>
-        </p:spPr>
-      </p:sp>
-      <p:pic>
-        <p:nvPicPr>
-          <p:cNvPr id="60" name="Image 7" descr="flow icon from tabler-icons (MIT)">    </p:cNvPr>
-          <p:cNvPicPr>
-            <a:picLocks noChangeAspect="1"/>
-          </p:cNvPicPr>
-          <p:nvPr/>
-        </p:nvPicPr>
-        <p:blipFill>
-          <a:blip r:embed="rId15">
-            <a:extLst>
-              <a:ext uri="{96DAC541-7B7A-43D3-8B79-37D633B846F1}">
-                <asvg:svgBlip xmlns:asvg="http://schemas.microsoft.com/office/drawing/2016/SVG/main" r:embed="rId16"/>
-              </a:ext>
-            </a:extLst>
-          </a:blip>
-          <a:stretch>
-            <a:fillRect/>
-          </a:stretch>
-        </p:blipFill>
-        <p:spPr>
-          <a:xfrm>
-            <a:off x="6535674" y="4489704"/>
-            <a:ext cx="438912" cy="438912"/>
-          </a:xfrm>
-          <a:prstGeom prst="rect">
-            <a:avLst/>
-          </a:prstGeom>
-        </p:spPr>
-      </p:pic>
-      <p:sp>
-        <p:nvSpPr>
-          <p:cNvPr id="61" name="mdpr:1-2-e3669a:item-4:block-15-chunk-1"/>
-          <p:cNvSpPr txBox="1"/>
-          <p:nvPr/>
-        </p:nvSpPr>
-        <p:spPr>
-          <a:xfrm>
-            <a:off x="7175754" y="3913632"/>
-            <a:ext cx="3961638" cy="1591056"/>
-          </a:xfrm>
-          <a:prstGeom prst="rect">
-            <a:avLst/>
-          </a:prstGeom>
-          <a:noFill/>
-          <a:ln/>
-        </p:spPr>
-        <p:txBody>
-          <a:bodyPr wrap="square" lIns="0" tIns="25400" rIns="25400" bIns="0" rtlCol="0" anchor="ctr"/>
-          <a:lstStyle/>
           <a:p>
             <a:pPr algn="l" indent="0" marL="0">
               <a:lnSpc>
@@ -9647,7 +9060,7 @@
               <a:buNone/>
             </a:pPr>
             <a:r>
-              <a:rPr lang="en-US" sz="2200" b="1" dirty="0">
+              <a:rPr lang="en-US" sz="1800" b="1" dirty="0">
                 <a:solidFill>
                   <a:srgbClr val="0F766E"/>
                 </a:solidFill>
@@ -9655,8 +9068,11 @@
                 <a:ea typeface="Pretendard" pitchFamily="34" charset="-122"/>
                 <a:cs typeface="Pretendard" pitchFamily="34" charset="-120"/>
               </a:rPr>
-              <a:t>Connectors</a:t>
+              <a:t>- Connectors</a:t>
             </a:r>
+            <a:endParaRPr lang="en-US" sz="1800" dirty="0"/>
+          </a:p>
+          <a:p>
             <a:pPr algn="l" indent="0" marL="0">
               <a:lnSpc>
                 <a:spcPct val="120000"/>
@@ -9664,7 +9080,7 @@
               <a:buNone/>
             </a:pPr>
             <a:r>
-              <a:rPr lang="en-US" sz="2200" dirty="0">
+              <a:rPr lang="en-US" sz="1800" dirty="0">
                 <a:solidFill>
                   <a:srgbClr val="111111"/>
                 </a:solidFill>
@@ -9674,7 +9090,7 @@
               </a:rPr>
               <a:t>  straight-arrow, elbow-arrow, boundary-attach, overlap-joint, parallel-flow, contrast-flow.</a:t>
             </a:r>
-            <a:endParaRPr lang="en-US" sz="2200" dirty="0"/>
+            <a:endParaRPr lang="en-US" sz="1800" dirty="0"/>
           </a:p>
         </p:txBody>
       </p:sp>
@@ -20696,71 +20112,14 @@
       </p:sp>
       <p:sp>
         <p:nvSpPr>
-          <p:cNvPr id="48" name="Shape 43"/>
-          <p:cNvSpPr/>
-          <p:nvPr/>
-        </p:nvSpPr>
-        <p:spPr>
-          <a:xfrm>
-            <a:off x="1097280" y="2140428"/>
-            <a:ext cx="474025" cy="474025"/>
-          </a:xfrm>
-          <a:prstGeom prst="roundRect">
-            <a:avLst>
-              <a:gd name="adj" fmla="val 7716"/>
-            </a:avLst>
-          </a:prstGeom>
-          <a:solidFill>
-            <a:srgbClr val="F8FAFC"/>
-          </a:solidFill>
-          <a:ln w="12700">
-            <a:solidFill>
-              <a:srgbClr val="CBD5E1"/>
-            </a:solidFill>
-            <a:prstDash val="solid"/>
-          </a:ln>
-        </p:spPr>
-      </p:sp>
-      <p:pic>
-        <p:nvPicPr>
-          <p:cNvPr id="49" name="Image 3" descr="article icon from tabler-icons (MIT)">    </p:cNvPr>
-          <p:cNvPicPr>
-            <a:picLocks noChangeAspect="1"/>
-          </p:cNvPicPr>
-          <p:nvPr/>
-        </p:nvPicPr>
-        <p:blipFill>
-          <a:blip r:embed="rId7">
-            <a:extLst>
-              <a:ext uri="{96DAC541-7B7A-43D3-8B79-37D633B846F1}">
-                <asvg:svgBlip xmlns:asvg="http://schemas.microsoft.com/office/drawing/2016/SVG/main" r:embed="rId8"/>
-              </a:ext>
-            </a:extLst>
-          </a:blip>
-          <a:stretch>
-            <a:fillRect/>
-          </a:stretch>
-        </p:blipFill>
-        <p:spPr>
-          <a:xfrm>
-            <a:off x="1170432" y="2213580"/>
-            <a:ext cx="327721" cy="327721"/>
-          </a:xfrm>
-          <a:prstGeom prst="rect">
-            <a:avLst/>
-          </a:prstGeom>
-        </p:spPr>
-      </p:pic>
-      <p:sp>
-        <p:nvSpPr>
-          <p:cNvPr id="50" name="mdpr:1-2-ea42c8:item-1:block-27-chunk-1"/>
+          <p:cNvPr id="48" name="mdpr:1-2-ea42c8:item-1:block-27-chunk-1"/>
           <p:cNvSpPr txBox="1"/>
           <p:nvPr/>
         </p:nvSpPr>
         <p:spPr>
           <a:xfrm>
-            <a:off x="1699321" y="1987296"/>
-            <a:ext cx="9255191" cy="780288"/>
+            <a:off x="1133856" y="1957548"/>
+            <a:ext cx="9820656" cy="839785"/>
           </a:xfrm>
           <a:prstGeom prst="rect">
             <a:avLst/>
@@ -20812,71 +20171,14 @@
       </p:sp>
       <p:sp>
         <p:nvSpPr>
-          <p:cNvPr id="51" name="Shape 45"/>
-          <p:cNvSpPr/>
-          <p:nvPr/>
-        </p:nvSpPr>
-        <p:spPr>
-          <a:xfrm>
-            <a:off x="1097280" y="3466308"/>
-            <a:ext cx="474025" cy="474025"/>
-          </a:xfrm>
-          <a:prstGeom prst="roundRect">
-            <a:avLst>
-              <a:gd name="adj" fmla="val 7716"/>
-            </a:avLst>
-          </a:prstGeom>
-          <a:solidFill>
-            <a:srgbClr val="F8FAFC"/>
-          </a:solidFill>
-          <a:ln w="12700">
-            <a:solidFill>
-              <a:srgbClr val="CBD5E1"/>
-            </a:solidFill>
-            <a:prstDash val="solid"/>
-          </a:ln>
-        </p:spPr>
-      </p:sp>
-      <p:pic>
-        <p:nvPicPr>
-          <p:cNvPr id="52" name="Image 4" descr="article icon from tabler-icons (MIT)">    </p:cNvPr>
-          <p:cNvPicPr>
-            <a:picLocks noChangeAspect="1"/>
-          </p:cNvPicPr>
-          <p:nvPr/>
-        </p:nvPicPr>
-        <p:blipFill>
-          <a:blip r:embed="rId9">
-            <a:extLst>
-              <a:ext uri="{96DAC541-7B7A-43D3-8B79-37D633B846F1}">
-                <asvg:svgBlip xmlns:asvg="http://schemas.microsoft.com/office/drawing/2016/SVG/main" r:embed="rId10"/>
-              </a:ext>
-            </a:extLst>
-          </a:blip>
-          <a:stretch>
-            <a:fillRect/>
-          </a:stretch>
-        </p:blipFill>
-        <p:spPr>
-          <a:xfrm>
-            <a:off x="1170432" y="3539460"/>
-            <a:ext cx="327721" cy="327721"/>
-          </a:xfrm>
-          <a:prstGeom prst="rect">
-            <a:avLst/>
-          </a:prstGeom>
-        </p:spPr>
-      </p:pic>
-      <p:sp>
-        <p:nvSpPr>
-          <p:cNvPr id="53" name="mdpr:1-2-ea42c8:item-2:block-27-chunk-1"/>
+          <p:cNvPr id="49" name="mdpr:1-2-ea42c8:item-2:block-27-chunk-1"/>
           <p:cNvSpPr txBox="1"/>
           <p:nvPr/>
         </p:nvSpPr>
         <p:spPr>
           <a:xfrm>
-            <a:off x="1699321" y="3313176"/>
-            <a:ext cx="9255191" cy="780288"/>
+            <a:off x="1133856" y="3283428"/>
+            <a:ext cx="9820656" cy="839785"/>
           </a:xfrm>
           <a:prstGeom prst="rect">
             <a:avLst/>
@@ -20928,71 +20230,14 @@
       </p:sp>
       <p:sp>
         <p:nvSpPr>
-          <p:cNvPr id="54" name="Shape 47"/>
-          <p:cNvSpPr/>
-          <p:nvPr/>
-        </p:nvSpPr>
-        <p:spPr>
-          <a:xfrm>
-            <a:off x="1097280" y="4783044"/>
-            <a:ext cx="474025" cy="474025"/>
-          </a:xfrm>
-          <a:prstGeom prst="roundRect">
-            <a:avLst>
-              <a:gd name="adj" fmla="val 7716"/>
-            </a:avLst>
-          </a:prstGeom>
-          <a:solidFill>
-            <a:srgbClr val="F8FAFC"/>
-          </a:solidFill>
-          <a:ln w="12700">
-            <a:solidFill>
-              <a:srgbClr val="CBD5E1"/>
-            </a:solidFill>
-            <a:prstDash val="solid"/>
-          </a:ln>
-        </p:spPr>
-      </p:sp>
-      <p:pic>
-        <p:nvPicPr>
-          <p:cNvPr id="55" name="Image 5" descr="article icon from tabler-icons (MIT)">    </p:cNvPr>
-          <p:cNvPicPr>
-            <a:picLocks noChangeAspect="1"/>
-          </p:cNvPicPr>
-          <p:nvPr/>
-        </p:nvPicPr>
-        <p:blipFill>
-          <a:blip r:embed="rId11">
-            <a:extLst>
-              <a:ext uri="{96DAC541-7B7A-43D3-8B79-37D633B846F1}">
-                <asvg:svgBlip xmlns:asvg="http://schemas.microsoft.com/office/drawing/2016/SVG/main" r:embed="rId12"/>
-              </a:ext>
-            </a:extLst>
-          </a:blip>
-          <a:stretch>
-            <a:fillRect/>
-          </a:stretch>
-        </p:blipFill>
-        <p:spPr>
-          <a:xfrm>
-            <a:off x="1170432" y="4856196"/>
-            <a:ext cx="327721" cy="327721"/>
-          </a:xfrm>
-          <a:prstGeom prst="rect">
-            <a:avLst/>
-          </a:prstGeom>
-        </p:spPr>
-      </p:pic>
-      <p:sp>
-        <p:nvSpPr>
-          <p:cNvPr id="56" name="mdpr:1-2-ea42c8:item-3:block-27-chunk-1"/>
+          <p:cNvPr id="50" name="mdpr:1-2-ea42c8:item-3:block-27-chunk-1"/>
           <p:cNvSpPr txBox="1"/>
           <p:nvPr/>
         </p:nvSpPr>
         <p:spPr>
           <a:xfrm>
-            <a:off x="1699321" y="4629912"/>
-            <a:ext cx="9255191" cy="780288"/>
+            <a:off x="1133856" y="4600164"/>
+            <a:ext cx="9820656" cy="839785"/>
           </a:xfrm>
           <a:prstGeom prst="rect">
             <a:avLst/>
@@ -25544,71 +24789,14 @@
       </p:sp>
       <p:sp>
         <p:nvSpPr>
-          <p:cNvPr id="50" name="Shape 44"/>
-          <p:cNvSpPr/>
-          <p:nvPr/>
-        </p:nvSpPr>
-        <p:spPr>
-          <a:xfrm>
-            <a:off x="976122" y="2130552"/>
-            <a:ext cx="585216" cy="585216"/>
-          </a:xfrm>
-          <a:prstGeom prst="roundRect">
-            <a:avLst>
-              <a:gd name="adj" fmla="val 6250"/>
-            </a:avLst>
-          </a:prstGeom>
-          <a:solidFill>
-            <a:srgbClr val="F8FAFC"/>
-          </a:solidFill>
-          <a:ln w="12700">
-            <a:solidFill>
-              <a:srgbClr val="CBD5E1"/>
-            </a:solidFill>
-            <a:prstDash val="solid"/>
-          </a:ln>
-        </p:spPr>
-      </p:sp>
-      <p:pic>
-        <p:nvPicPr>
-          <p:cNvPr id="51" name="Image 4" descr="article icon from tabler-icons (MIT)">    </p:cNvPr>
-          <p:cNvPicPr>
-            <a:picLocks noChangeAspect="1"/>
-          </p:cNvPicPr>
-          <p:nvPr/>
-        </p:nvPicPr>
-        <p:blipFill>
-          <a:blip r:embed="rId9">
-            <a:extLst>
-              <a:ext uri="{96DAC541-7B7A-43D3-8B79-37D633B846F1}">
-                <asvg:svgBlip xmlns:asvg="http://schemas.microsoft.com/office/drawing/2016/SVG/main" r:embed="rId10"/>
-              </a:ext>
-            </a:extLst>
-          </a:blip>
-          <a:stretch>
-            <a:fillRect/>
-          </a:stretch>
-        </p:blipFill>
-        <p:spPr>
-          <a:xfrm>
-            <a:off x="1049274" y="2203704"/>
-            <a:ext cx="438912" cy="438912"/>
-          </a:xfrm>
-          <a:prstGeom prst="rect">
-            <a:avLst/>
-          </a:prstGeom>
-        </p:spPr>
-      </p:pic>
-      <p:sp>
-        <p:nvSpPr>
-          <p:cNvPr id="52" name="mdpr:icon-and-text-aside-8429fc:item-1:block-29"/>
+          <p:cNvPr id="50" name="mdpr:icon-and-text-aside-8429fc:item-1:block-29"/>
           <p:cNvSpPr txBox="1"/>
           <p:nvPr/>
         </p:nvSpPr>
         <p:spPr>
           <a:xfrm>
-            <a:off x="1689354" y="2033016"/>
-            <a:ext cx="3961638" cy="780288"/>
+            <a:off x="1042416" y="1627632"/>
+            <a:ext cx="4608576" cy="1591056"/>
           </a:xfrm>
           <a:prstGeom prst="rect">
             <a:avLst/>
@@ -25660,71 +24848,14 @@
       </p:sp>
       <p:sp>
         <p:nvSpPr>
-          <p:cNvPr id="53" name="Shape 46"/>
-          <p:cNvSpPr/>
-          <p:nvPr/>
-        </p:nvSpPr>
-        <p:spPr>
-          <a:xfrm>
-            <a:off x="6462522" y="2130552"/>
-            <a:ext cx="585216" cy="585216"/>
-          </a:xfrm>
-          <a:prstGeom prst="roundRect">
-            <a:avLst>
-              <a:gd name="adj" fmla="val 6250"/>
-            </a:avLst>
-          </a:prstGeom>
-          <a:solidFill>
-            <a:srgbClr val="F8FAFC"/>
-          </a:solidFill>
-          <a:ln w="12700">
-            <a:solidFill>
-              <a:srgbClr val="CBD5E1"/>
-            </a:solidFill>
-            <a:prstDash val="solid"/>
-          </a:ln>
-        </p:spPr>
-      </p:sp>
-      <p:pic>
-        <p:nvPicPr>
-          <p:cNvPr id="54" name="Image 5" descr="article icon from tabler-icons (MIT)">    </p:cNvPr>
-          <p:cNvPicPr>
-            <a:picLocks noChangeAspect="1"/>
-          </p:cNvPicPr>
-          <p:nvPr/>
-        </p:nvPicPr>
-        <p:blipFill>
-          <a:blip r:embed="rId11">
-            <a:extLst>
-              <a:ext uri="{96DAC541-7B7A-43D3-8B79-37D633B846F1}">
-                <asvg:svgBlip xmlns:asvg="http://schemas.microsoft.com/office/drawing/2016/SVG/main" r:embed="rId12"/>
-              </a:ext>
-            </a:extLst>
-          </a:blip>
-          <a:stretch>
-            <a:fillRect/>
-          </a:stretch>
-        </p:blipFill>
-        <p:spPr>
-          <a:xfrm>
-            <a:off x="6535674" y="2203704"/>
-            <a:ext cx="438912" cy="438912"/>
-          </a:xfrm>
-          <a:prstGeom prst="rect">
-            <a:avLst/>
-          </a:prstGeom>
-        </p:spPr>
-      </p:pic>
-      <p:sp>
-        <p:nvSpPr>
-          <p:cNvPr id="55" name="mdpr:icon-and-text-aside-8429fc:item-2:block-29"/>
+          <p:cNvPr id="51" name="mdpr:icon-and-text-aside-8429fc:item-2:block-29"/>
           <p:cNvSpPr txBox="1"/>
           <p:nvPr/>
         </p:nvSpPr>
         <p:spPr>
           <a:xfrm>
-            <a:off x="7175754" y="1865376"/>
-            <a:ext cx="3961638" cy="1115568"/>
+            <a:off x="6528816" y="1627632"/>
+            <a:ext cx="4608576" cy="1591056"/>
           </a:xfrm>
           <a:prstGeom prst="rect">
             <a:avLst/>
@@ -25776,71 +24907,14 @@
       </p:sp>
       <p:sp>
         <p:nvSpPr>
-          <p:cNvPr id="56" name="Shape 48"/>
-          <p:cNvSpPr/>
-          <p:nvPr/>
-        </p:nvSpPr>
-        <p:spPr>
-          <a:xfrm>
-            <a:off x="976122" y="4416552"/>
-            <a:ext cx="585216" cy="585216"/>
-          </a:xfrm>
-          <a:prstGeom prst="roundRect">
-            <a:avLst>
-              <a:gd name="adj" fmla="val 6250"/>
-            </a:avLst>
-          </a:prstGeom>
-          <a:solidFill>
-            <a:srgbClr val="F8FAFC"/>
-          </a:solidFill>
-          <a:ln w="12700">
-            <a:solidFill>
-              <a:srgbClr val="CBD5E1"/>
-            </a:solidFill>
-            <a:prstDash val="solid"/>
-          </a:ln>
-        </p:spPr>
-      </p:sp>
-      <p:pic>
-        <p:nvPicPr>
-          <p:cNvPr id="57" name="Image 6" descr="article icon from tabler-icons (MIT)">    </p:cNvPr>
-          <p:cNvPicPr>
-            <a:picLocks noChangeAspect="1"/>
-          </p:cNvPicPr>
-          <p:nvPr/>
-        </p:nvPicPr>
-        <p:blipFill>
-          <a:blip r:embed="rId13">
-            <a:extLst>
-              <a:ext uri="{96DAC541-7B7A-43D3-8B79-37D633B846F1}">
-                <asvg:svgBlip xmlns:asvg="http://schemas.microsoft.com/office/drawing/2016/SVG/main" r:embed="rId14"/>
-              </a:ext>
-            </a:extLst>
-          </a:blip>
-          <a:stretch>
-            <a:fillRect/>
-          </a:stretch>
-        </p:blipFill>
-        <p:spPr>
-          <a:xfrm>
-            <a:off x="1049274" y="4489704"/>
-            <a:ext cx="438912" cy="438912"/>
-          </a:xfrm>
-          <a:prstGeom prst="rect">
-            <a:avLst/>
-          </a:prstGeom>
-        </p:spPr>
-      </p:pic>
-      <p:sp>
-        <p:nvSpPr>
-          <p:cNvPr id="58" name="mdpr:icon-and-text-aside-8429fc:item-3:block-29"/>
+          <p:cNvPr id="52" name="mdpr:icon-and-text-aside-8429fc:item-3:block-29"/>
           <p:cNvSpPr txBox="1"/>
           <p:nvPr/>
         </p:nvSpPr>
         <p:spPr>
           <a:xfrm>
-            <a:off x="1689354" y="4151376"/>
-            <a:ext cx="3961638" cy="1115568"/>
+            <a:off x="1042416" y="3913632"/>
+            <a:ext cx="4608576" cy="1591056"/>
           </a:xfrm>
           <a:prstGeom prst="rect">
             <a:avLst/>
@@ -25892,71 +24966,14 @@
       </p:sp>
       <p:sp>
         <p:nvSpPr>
-          <p:cNvPr id="59" name="Shape 50"/>
-          <p:cNvSpPr/>
-          <p:nvPr/>
-        </p:nvSpPr>
-        <p:spPr>
-          <a:xfrm>
-            <a:off x="6462522" y="4416552"/>
-            <a:ext cx="585216" cy="585216"/>
-          </a:xfrm>
-          <a:prstGeom prst="roundRect">
-            <a:avLst>
-              <a:gd name="adj" fmla="val 6250"/>
-            </a:avLst>
-          </a:prstGeom>
-          <a:solidFill>
-            <a:srgbClr val="F8FAFC"/>
-          </a:solidFill>
-          <a:ln w="12700">
-            <a:solidFill>
-              <a:srgbClr val="CBD5E1"/>
-            </a:solidFill>
-            <a:prstDash val="solid"/>
-          </a:ln>
-        </p:spPr>
-      </p:sp>
-      <p:pic>
-        <p:nvPicPr>
-          <p:cNvPr id="60" name="Image 7" descr="table icon from tabler-icons (MIT)">    </p:cNvPr>
-          <p:cNvPicPr>
-            <a:picLocks noChangeAspect="1"/>
-          </p:cNvPicPr>
-          <p:nvPr/>
-        </p:nvPicPr>
-        <p:blipFill>
-          <a:blip r:embed="rId15">
-            <a:extLst>
-              <a:ext uri="{96DAC541-7B7A-43D3-8B79-37D633B846F1}">
-                <asvg:svgBlip xmlns:asvg="http://schemas.microsoft.com/office/drawing/2016/SVG/main" r:embed="rId16"/>
-              </a:ext>
-            </a:extLst>
-          </a:blip>
-          <a:stretch>
-            <a:fillRect/>
-          </a:stretch>
-        </p:blipFill>
-        <p:spPr>
-          <a:xfrm>
-            <a:off x="6535674" y="4489704"/>
-            <a:ext cx="438912" cy="438912"/>
-          </a:xfrm>
-          <a:prstGeom prst="rect">
-            <a:avLst/>
-          </a:prstGeom>
-        </p:spPr>
-      </p:pic>
-      <p:sp>
-        <p:nvSpPr>
-          <p:cNvPr id="61" name="mdpr:icon-and-text-aside-8429fc:item-4:block-29"/>
+          <p:cNvPr id="53" name="mdpr:icon-and-text-aside-8429fc:item-4:block-29"/>
           <p:cNvSpPr txBox="1"/>
           <p:nvPr/>
         </p:nvSpPr>
         <p:spPr>
           <a:xfrm>
-            <a:off x="7175754" y="4151376"/>
-            <a:ext cx="3961638" cy="1115568"/>
+            <a:off x="6528816" y="3913632"/>
+            <a:ext cx="4608576" cy="1591056"/>
           </a:xfrm>
           <a:prstGeom prst="rect">
             <a:avLst/>
@@ -27349,71 +26366,14 @@
       </p:sp>
       <p:sp>
         <p:nvSpPr>
-          <p:cNvPr id="50" name="Shape 44"/>
-          <p:cNvSpPr/>
-          <p:nvPr/>
-        </p:nvSpPr>
-        <p:spPr>
-          <a:xfrm>
-            <a:off x="976122" y="2130552"/>
-            <a:ext cx="585216" cy="585216"/>
-          </a:xfrm>
-          <a:prstGeom prst="roundRect">
-            <a:avLst>
-              <a:gd name="adj" fmla="val 6250"/>
-            </a:avLst>
-          </a:prstGeom>
-          <a:solidFill>
-            <a:srgbClr val="F8FAFC"/>
-          </a:solidFill>
-          <a:ln w="12700">
-            <a:solidFill>
-              <a:srgbClr val="CBD5E1"/>
-            </a:solidFill>
-            <a:prstDash val="solid"/>
-          </a:ln>
-        </p:spPr>
-      </p:sp>
-      <p:pic>
-        <p:nvPicPr>
-          <p:cNvPr id="51" name="Image 4" descr="verified icon from tabler-icons (MIT)">    </p:cNvPr>
-          <p:cNvPicPr>
-            <a:picLocks noChangeAspect="1"/>
-          </p:cNvPicPr>
-          <p:nvPr/>
-        </p:nvPicPr>
-        <p:blipFill>
-          <a:blip r:embed="rId9">
-            <a:extLst>
-              <a:ext uri="{96DAC541-7B7A-43D3-8B79-37D633B846F1}">
-                <asvg:svgBlip xmlns:asvg="http://schemas.microsoft.com/office/drawing/2016/SVG/main" r:embed="rId10"/>
-              </a:ext>
-            </a:extLst>
-          </a:blip>
-          <a:stretch>
-            <a:fillRect/>
-          </a:stretch>
-        </p:blipFill>
-        <p:spPr>
-          <a:xfrm>
-            <a:off x="1049274" y="2203704"/>
-            <a:ext cx="438912" cy="438912"/>
-          </a:xfrm>
-          <a:prstGeom prst="rect">
-            <a:avLst/>
-          </a:prstGeom>
-        </p:spPr>
-      </p:pic>
-      <p:sp>
-        <p:nvSpPr>
-          <p:cNvPr id="52" name="mdpr:overflow-guard-f8d03e:item-1:block-31"/>
+          <p:cNvPr id="50" name="mdpr:overflow-guard-f8d03e:item-1:block-31"/>
           <p:cNvSpPr txBox="1"/>
           <p:nvPr/>
         </p:nvSpPr>
         <p:spPr>
           <a:xfrm>
-            <a:off x="1689354" y="1865376"/>
-            <a:ext cx="3961638" cy="1115568"/>
+            <a:off x="1042416" y="1627632"/>
+            <a:ext cx="4608576" cy="1591056"/>
           </a:xfrm>
           <a:prstGeom prst="rect">
             <a:avLst/>
@@ -27465,71 +26425,14 @@
       </p:sp>
       <p:sp>
         <p:nvSpPr>
-          <p:cNvPr id="53" name="Shape 46"/>
-          <p:cNvSpPr/>
-          <p:nvPr/>
-        </p:nvSpPr>
-        <p:spPr>
-          <a:xfrm>
-            <a:off x="6462522" y="2130552"/>
-            <a:ext cx="585216" cy="585216"/>
-          </a:xfrm>
-          <a:prstGeom prst="roundRect">
-            <a:avLst>
-              <a:gd name="adj" fmla="val 6250"/>
-            </a:avLst>
-          </a:prstGeom>
-          <a:solidFill>
-            <a:srgbClr val="F8FAFC"/>
-          </a:solidFill>
-          <a:ln w="12700">
-            <a:solidFill>
-              <a:srgbClr val="CBD5E1"/>
-            </a:solidFill>
-            <a:prstDash val="solid"/>
-          </a:ln>
-        </p:spPr>
-      </p:sp>
-      <p:pic>
-        <p:nvPicPr>
-          <p:cNvPr id="54" name="Image 5" descr="table icon from tabler-icons (MIT)">    </p:cNvPr>
-          <p:cNvPicPr>
-            <a:picLocks noChangeAspect="1"/>
-          </p:cNvPicPr>
-          <p:nvPr/>
-        </p:nvPicPr>
-        <p:blipFill>
-          <a:blip r:embed="rId11">
-            <a:extLst>
-              <a:ext uri="{96DAC541-7B7A-43D3-8B79-37D633B846F1}">
-                <asvg:svgBlip xmlns:asvg="http://schemas.microsoft.com/office/drawing/2016/SVG/main" r:embed="rId12"/>
-              </a:ext>
-            </a:extLst>
-          </a:blip>
-          <a:stretch>
-            <a:fillRect/>
-          </a:stretch>
-        </p:blipFill>
-        <p:spPr>
-          <a:xfrm>
-            <a:off x="6535674" y="2203704"/>
-            <a:ext cx="438912" cy="438912"/>
-          </a:xfrm>
-          <a:prstGeom prst="rect">
-            <a:avLst/>
-          </a:prstGeom>
-        </p:spPr>
-      </p:pic>
-      <p:sp>
-        <p:nvSpPr>
-          <p:cNvPr id="55" name="mdpr:overflow-guard-f8d03e:item-2:block-31"/>
+          <p:cNvPr id="51" name="mdpr:overflow-guard-f8d03e:item-2:block-31"/>
           <p:cNvSpPr txBox="1"/>
           <p:nvPr/>
         </p:nvSpPr>
         <p:spPr>
           <a:xfrm>
-            <a:off x="7175754" y="1697736"/>
-            <a:ext cx="3961638" cy="1450848"/>
+            <a:off x="6528816" y="1627632"/>
+            <a:ext cx="4608576" cy="1591056"/>
           </a:xfrm>
           <a:prstGeom prst="rect">
             <a:avLst/>
@@ -27581,71 +26484,14 @@
       </p:sp>
       <p:sp>
         <p:nvSpPr>
-          <p:cNvPr id="56" name="Shape 48"/>
-          <p:cNvSpPr/>
-          <p:nvPr/>
-        </p:nvSpPr>
-        <p:spPr>
-          <a:xfrm>
-            <a:off x="976122" y="4416552"/>
-            <a:ext cx="585216" cy="585216"/>
-          </a:xfrm>
-          <a:prstGeom prst="roundRect">
-            <a:avLst>
-              <a:gd name="adj" fmla="val 6250"/>
-            </a:avLst>
-          </a:prstGeom>
-          <a:solidFill>
-            <a:srgbClr val="F8FAFC"/>
-          </a:solidFill>
-          <a:ln w="12700">
-            <a:solidFill>
-              <a:srgbClr val="CBD5E1"/>
-            </a:solidFill>
-            <a:prstDash val="solid"/>
-          </a:ln>
-        </p:spPr>
-      </p:sp>
-      <p:pic>
-        <p:nvPicPr>
-          <p:cNvPr id="57" name="Image 6" descr="article icon from tabler-icons (MIT)">    </p:cNvPr>
-          <p:cNvPicPr>
-            <a:picLocks noChangeAspect="1"/>
-          </p:cNvPicPr>
-          <p:nvPr/>
-        </p:nvPicPr>
-        <p:blipFill>
-          <a:blip r:embed="rId13">
-            <a:extLst>
-              <a:ext uri="{96DAC541-7B7A-43D3-8B79-37D633B846F1}">
-                <asvg:svgBlip xmlns:asvg="http://schemas.microsoft.com/office/drawing/2016/SVG/main" r:embed="rId14"/>
-              </a:ext>
-            </a:extLst>
-          </a:blip>
-          <a:stretch>
-            <a:fillRect/>
-          </a:stretch>
-        </p:blipFill>
-        <p:spPr>
-          <a:xfrm>
-            <a:off x="1049274" y="4489704"/>
-            <a:ext cx="438912" cy="438912"/>
-          </a:xfrm>
-          <a:prstGeom prst="rect">
-            <a:avLst/>
-          </a:prstGeom>
-        </p:spPr>
-      </p:pic>
-      <p:sp>
-        <p:nvSpPr>
-          <p:cNvPr id="58" name="mdpr:overflow-guard-f8d03e:item-3:block-31"/>
+          <p:cNvPr id="52" name="mdpr:overflow-guard-f8d03e:item-3:block-31"/>
           <p:cNvSpPr txBox="1"/>
           <p:nvPr/>
         </p:nvSpPr>
         <p:spPr>
           <a:xfrm>
-            <a:off x="1689354" y="4151376"/>
-            <a:ext cx="3961638" cy="1115568"/>
+            <a:off x="1042416" y="3913632"/>
+            <a:ext cx="4608576" cy="1591056"/>
           </a:xfrm>
           <a:prstGeom prst="rect">
             <a:avLst/>
@@ -27697,71 +26543,14 @@
       </p:sp>
       <p:sp>
         <p:nvSpPr>
-          <p:cNvPr id="59" name="Shape 50"/>
-          <p:cNvSpPr/>
-          <p:nvPr/>
-        </p:nvSpPr>
-        <p:spPr>
-          <a:xfrm>
-            <a:off x="6462522" y="4416552"/>
-            <a:ext cx="585216" cy="585216"/>
-          </a:xfrm>
-          <a:prstGeom prst="roundRect">
-            <a:avLst>
-              <a:gd name="adj" fmla="val 6250"/>
-            </a:avLst>
-          </a:prstGeom>
-          <a:solidFill>
-            <a:srgbClr val="F8FAFC"/>
-          </a:solidFill>
-          <a:ln w="12700">
-            <a:solidFill>
-              <a:srgbClr val="CBD5E1"/>
-            </a:solidFill>
-            <a:prstDash val="solid"/>
-          </a:ln>
-        </p:spPr>
-      </p:sp>
-      <p:pic>
-        <p:nvPicPr>
-          <p:cNvPr id="60" name="Image 7" descr="article icon from tabler-icons (MIT)">    </p:cNvPr>
-          <p:cNvPicPr>
-            <a:picLocks noChangeAspect="1"/>
-          </p:cNvPicPr>
-          <p:nvPr/>
-        </p:nvPicPr>
-        <p:blipFill>
-          <a:blip r:embed="rId15">
-            <a:extLst>
-              <a:ext uri="{96DAC541-7B7A-43D3-8B79-37D633B846F1}">
-                <asvg:svgBlip xmlns:asvg="http://schemas.microsoft.com/office/drawing/2016/SVG/main" r:embed="rId16"/>
-              </a:ext>
-            </a:extLst>
-          </a:blip>
-          <a:stretch>
-            <a:fillRect/>
-          </a:stretch>
-        </p:blipFill>
-        <p:spPr>
-          <a:xfrm>
-            <a:off x="6535674" y="4489704"/>
-            <a:ext cx="438912" cy="438912"/>
-          </a:xfrm>
-          <a:prstGeom prst="rect">
-            <a:avLst/>
-          </a:prstGeom>
-        </p:spPr>
-      </p:pic>
-      <p:sp>
-        <p:nvSpPr>
-          <p:cNvPr id="61" name="mdpr:overflow-guard-f8d03e:item-4:block-31"/>
+          <p:cNvPr id="53" name="mdpr:overflow-guard-f8d03e:item-4:block-31"/>
           <p:cNvSpPr txBox="1"/>
           <p:nvPr/>
         </p:nvSpPr>
         <p:spPr>
           <a:xfrm>
-            <a:off x="7175754" y="4151376"/>
-            <a:ext cx="3961638" cy="1115568"/>
+            <a:off x="6528816" y="3913632"/>
+            <a:ext cx="4608576" cy="1591056"/>
           </a:xfrm>
           <a:prstGeom prst="rect">
             <a:avLst/>
@@ -32102,71 +30891,14 @@
       </p:sp>
       <p:sp>
         <p:nvSpPr>
-          <p:cNvPr id="48" name="Shape 43"/>
-          <p:cNvSpPr/>
-          <p:nvPr/>
-        </p:nvSpPr>
-        <p:spPr>
-          <a:xfrm>
-            <a:off x="1097280" y="2140428"/>
-            <a:ext cx="474025" cy="474025"/>
-          </a:xfrm>
-          <a:prstGeom prst="roundRect">
-            <a:avLst>
-              <a:gd name="adj" fmla="val 7716"/>
-            </a:avLst>
-          </a:prstGeom>
-          <a:solidFill>
-            <a:srgbClr val="F8FAFC"/>
-          </a:solidFill>
-          <a:ln w="12700">
-            <a:solidFill>
-              <a:srgbClr val="CBD5E1"/>
-            </a:solidFill>
-            <a:prstDash val="solid"/>
-          </a:ln>
-        </p:spPr>
-      </p:sp>
-      <p:pic>
-        <p:nvPicPr>
-          <p:cNvPr id="49" name="Image 3" descr="flow icon from tabler-icons (MIT)">    </p:cNvPr>
-          <p:cNvPicPr>
-            <a:picLocks noChangeAspect="1"/>
-          </p:cNvPicPr>
-          <p:nvPr/>
-        </p:nvPicPr>
-        <p:blipFill>
-          <a:blip r:embed="rId7">
-            <a:extLst>
-              <a:ext uri="{96DAC541-7B7A-43D3-8B79-37D633B846F1}">
-                <asvg:svgBlip xmlns:asvg="http://schemas.microsoft.com/office/drawing/2016/SVG/main" r:embed="rId8"/>
-              </a:ext>
-            </a:extLst>
-          </a:blip>
-          <a:stretch>
-            <a:fillRect/>
-          </a:stretch>
-        </p:blipFill>
-        <p:spPr>
-          <a:xfrm>
-            <a:off x="1170432" y="2213580"/>
-            <a:ext cx="327721" cy="327721"/>
-          </a:xfrm>
-          <a:prstGeom prst="rect">
-            <a:avLst/>
-          </a:prstGeom>
-        </p:spPr>
-      </p:pic>
-      <p:sp>
-        <p:nvSpPr>
-          <p:cNvPr id="50" name="mdpr:actions-output-review-326e07:item-1:block-41"/>
+          <p:cNvPr id="48" name="mdpr:actions-output-review-326e07:item-1:block-41"/>
           <p:cNvSpPr txBox="1"/>
           <p:nvPr/>
         </p:nvSpPr>
         <p:spPr>
           <a:xfrm>
-            <a:off x="1699321" y="1987296"/>
-            <a:ext cx="9255191" cy="780288"/>
+            <a:off x="1133856" y="1957548"/>
+            <a:ext cx="9820656" cy="839785"/>
           </a:xfrm>
           <a:prstGeom prst="rect">
             <a:avLst/>
@@ -32218,71 +30950,14 @@
       </p:sp>
       <p:sp>
         <p:nvSpPr>
-          <p:cNvPr id="51" name="Shape 45"/>
-          <p:cNvSpPr/>
-          <p:nvPr/>
-        </p:nvSpPr>
-        <p:spPr>
-          <a:xfrm>
-            <a:off x="1097280" y="3466308"/>
-            <a:ext cx="474025" cy="474025"/>
-          </a:xfrm>
-          <a:prstGeom prst="roundRect">
-            <a:avLst>
-              <a:gd name="adj" fmla="val 7716"/>
-            </a:avLst>
-          </a:prstGeom>
-          <a:solidFill>
-            <a:srgbClr val="F8FAFC"/>
-          </a:solidFill>
-          <a:ln w="12700">
-            <a:solidFill>
-              <a:srgbClr val="CBD5E1"/>
-            </a:solidFill>
-            <a:prstDash val="solid"/>
-          </a:ln>
-        </p:spPr>
-      </p:sp>
-      <p:pic>
-        <p:nvPicPr>
-          <p:cNvPr id="52" name="Image 4" descr="verified icon from tabler-icons (MIT)">    </p:cNvPr>
-          <p:cNvPicPr>
-            <a:picLocks noChangeAspect="1"/>
-          </p:cNvPicPr>
-          <p:nvPr/>
-        </p:nvPicPr>
-        <p:blipFill>
-          <a:blip r:embed="rId9">
-            <a:extLst>
-              <a:ext uri="{96DAC541-7B7A-43D3-8B79-37D633B846F1}">
-                <asvg:svgBlip xmlns:asvg="http://schemas.microsoft.com/office/drawing/2016/SVG/main" r:embed="rId10"/>
-              </a:ext>
-            </a:extLst>
-          </a:blip>
-          <a:stretch>
-            <a:fillRect/>
-          </a:stretch>
-        </p:blipFill>
-        <p:spPr>
-          <a:xfrm>
-            <a:off x="1170432" y="3539460"/>
-            <a:ext cx="327721" cy="327721"/>
-          </a:xfrm>
-          <a:prstGeom prst="rect">
-            <a:avLst/>
-          </a:prstGeom>
-        </p:spPr>
-      </p:pic>
-      <p:sp>
-        <p:nvSpPr>
-          <p:cNvPr id="53" name="mdpr:actions-output-review-326e07:item-2:block-41"/>
+          <p:cNvPr id="49" name="mdpr:actions-output-review-326e07:item-2:block-41"/>
           <p:cNvSpPr txBox="1"/>
           <p:nvPr/>
         </p:nvSpPr>
         <p:spPr>
           <a:xfrm>
-            <a:off x="1699321" y="3313176"/>
-            <a:ext cx="9255191" cy="780288"/>
+            <a:off x="1133856" y="3283428"/>
+            <a:ext cx="9820656" cy="839785"/>
           </a:xfrm>
           <a:prstGeom prst="rect">
             <a:avLst/>
@@ -32334,71 +31009,14 @@
       </p:sp>
       <p:sp>
         <p:nvSpPr>
-          <p:cNvPr id="54" name="Shape 47"/>
-          <p:cNvSpPr/>
-          <p:nvPr/>
-        </p:nvSpPr>
-        <p:spPr>
-          <a:xfrm>
-            <a:off x="1097280" y="4783044"/>
-            <a:ext cx="474025" cy="474025"/>
-          </a:xfrm>
-          <a:prstGeom prst="roundRect">
-            <a:avLst>
-              <a:gd name="adj" fmla="val 7716"/>
-            </a:avLst>
-          </a:prstGeom>
-          <a:solidFill>
-            <a:srgbClr val="F8FAFC"/>
-          </a:solidFill>
-          <a:ln w="12700">
-            <a:solidFill>
-              <a:srgbClr val="CBD5E1"/>
-            </a:solidFill>
-            <a:prstDash val="solid"/>
-          </a:ln>
-        </p:spPr>
-      </p:sp>
-      <p:pic>
-        <p:nvPicPr>
-          <p:cNvPr id="55" name="Image 5" descr="spark icon from tabler-icons (MIT)">    </p:cNvPr>
-          <p:cNvPicPr>
-            <a:picLocks noChangeAspect="1"/>
-          </p:cNvPicPr>
-          <p:nvPr/>
-        </p:nvPicPr>
-        <p:blipFill>
-          <a:blip r:embed="rId11">
-            <a:extLst>
-              <a:ext uri="{96DAC541-7B7A-43D3-8B79-37D633B846F1}">
-                <asvg:svgBlip xmlns:asvg="http://schemas.microsoft.com/office/drawing/2016/SVG/main" r:embed="rId12"/>
-              </a:ext>
-            </a:extLst>
-          </a:blip>
-          <a:stretch>
-            <a:fillRect/>
-          </a:stretch>
-        </p:blipFill>
-        <p:spPr>
-          <a:xfrm>
-            <a:off x="1170432" y="4856196"/>
-            <a:ext cx="327721" cy="327721"/>
-          </a:xfrm>
-          <a:prstGeom prst="rect">
-            <a:avLst/>
-          </a:prstGeom>
-        </p:spPr>
-      </p:pic>
-      <p:sp>
-        <p:nvSpPr>
-          <p:cNvPr id="56" name="mdpr:actions-output-review-326e07:item-3:block-41"/>
+          <p:cNvPr id="50" name="mdpr:actions-output-review-326e07:item-3:block-41"/>
           <p:cNvSpPr txBox="1"/>
           <p:nvPr/>
         </p:nvSpPr>
         <p:spPr>
           <a:xfrm>
-            <a:off x="1699321" y="4629912"/>
-            <a:ext cx="9255191" cy="780288"/>
+            <a:off x="1133856" y="4600164"/>
+            <a:ext cx="9820656" cy="839785"/>
           </a:xfrm>
           <a:prstGeom prst="rect">
             <a:avLst/>
@@ -36131,71 +34749,14 @@
       </p:sp>
       <p:sp>
         <p:nvSpPr>
-          <p:cNvPr id="48" name="Shape 43"/>
-          <p:cNvSpPr/>
-          <p:nvPr/>
-        </p:nvSpPr>
-        <p:spPr>
-          <a:xfrm>
-            <a:off x="1097280" y="2140428"/>
-            <a:ext cx="474025" cy="474025"/>
-          </a:xfrm>
-          <a:prstGeom prst="roundRect">
-            <a:avLst>
-              <a:gd name="adj" fmla="val 7716"/>
-            </a:avLst>
-          </a:prstGeom>
-          <a:solidFill>
-            <a:srgbClr val="F8FAFC"/>
-          </a:solidFill>
-          <a:ln w="12700">
-            <a:solidFill>
-              <a:srgbClr val="CBD5E1"/>
-            </a:solidFill>
-            <a:prstDash val="solid"/>
-          </a:ln>
-        </p:spPr>
-      </p:sp>
-      <p:pic>
-        <p:nvPicPr>
-          <p:cNvPr id="49" name="Image 3" descr="article icon from tabler-icons (MIT)">    </p:cNvPr>
-          <p:cNvPicPr>
-            <a:picLocks noChangeAspect="1"/>
-          </p:cNvPicPr>
-          <p:nvPr/>
-        </p:nvPicPr>
-        <p:blipFill>
-          <a:blip r:embed="rId7">
-            <a:extLst>
-              <a:ext uri="{96DAC541-7B7A-43D3-8B79-37D633B846F1}">
-                <asvg:svgBlip xmlns:asvg="http://schemas.microsoft.com/office/drawing/2016/SVG/main" r:embed="rId8"/>
-              </a:ext>
-            </a:extLst>
-          </a:blip>
-          <a:stretch>
-            <a:fillRect/>
-          </a:stretch>
-        </p:blipFill>
-        <p:spPr>
-          <a:xfrm>
-            <a:off x="1170432" y="2213580"/>
-            <a:ext cx="327721" cy="327721"/>
-          </a:xfrm>
-          <a:prstGeom prst="rect">
-            <a:avLst/>
-          </a:prstGeom>
-        </p:spPr>
-      </p:pic>
-      <p:sp>
-        <p:nvSpPr>
-          <p:cNvPr id="50" name="mdpr:1-2-32ac08:item-1:block-6-chunk-1"/>
+          <p:cNvPr id="48" name="mdpr:1-2-32ac08:item-1:block-6-chunk-1"/>
           <p:cNvSpPr txBox="1"/>
           <p:nvPr/>
         </p:nvSpPr>
         <p:spPr>
           <a:xfrm>
-            <a:off x="1699321" y="1987296"/>
-            <a:ext cx="9255191" cy="780288"/>
+            <a:off x="1133856" y="1957548"/>
+            <a:ext cx="9820656" cy="839785"/>
           </a:xfrm>
           <a:prstGeom prst="rect">
             <a:avLst/>
@@ -36247,71 +34808,14 @@
       </p:sp>
       <p:sp>
         <p:nvSpPr>
-          <p:cNvPr id="51" name="Shape 45"/>
-          <p:cNvSpPr/>
-          <p:nvPr/>
-        </p:nvSpPr>
-        <p:spPr>
-          <a:xfrm>
-            <a:off x="1097280" y="3466308"/>
-            <a:ext cx="474025" cy="474025"/>
-          </a:xfrm>
-          <a:prstGeom prst="roundRect">
-            <a:avLst>
-              <a:gd name="adj" fmla="val 7716"/>
-            </a:avLst>
-          </a:prstGeom>
-          <a:solidFill>
-            <a:srgbClr val="F8FAFC"/>
-          </a:solidFill>
-          <a:ln w="12700">
-            <a:solidFill>
-              <a:srgbClr val="CBD5E1"/>
-            </a:solidFill>
-            <a:prstDash val="solid"/>
-          </a:ln>
-        </p:spPr>
-      </p:sp>
-      <p:pic>
-        <p:nvPicPr>
-          <p:cNvPr id="52" name="Image 4" descr="chart icon from tabler-icons (MIT)">    </p:cNvPr>
-          <p:cNvPicPr>
-            <a:picLocks noChangeAspect="1"/>
-          </p:cNvPicPr>
-          <p:nvPr/>
-        </p:nvPicPr>
-        <p:blipFill>
-          <a:blip r:embed="rId9">
-            <a:extLst>
-              <a:ext uri="{96DAC541-7B7A-43D3-8B79-37D633B846F1}">
-                <asvg:svgBlip xmlns:asvg="http://schemas.microsoft.com/office/drawing/2016/SVG/main" r:embed="rId10"/>
-              </a:ext>
-            </a:extLst>
-          </a:blip>
-          <a:stretch>
-            <a:fillRect/>
-          </a:stretch>
-        </p:blipFill>
-        <p:spPr>
-          <a:xfrm>
-            <a:off x="1170432" y="3539460"/>
-            <a:ext cx="327721" cy="327721"/>
-          </a:xfrm>
-          <a:prstGeom prst="rect">
-            <a:avLst/>
-          </a:prstGeom>
-        </p:spPr>
-      </p:pic>
-      <p:sp>
-        <p:nvSpPr>
-          <p:cNvPr id="53" name="mdpr:1-2-32ac08:item-2:block-6-chunk-1"/>
+          <p:cNvPr id="49" name="mdpr:1-2-32ac08:item-2:block-6-chunk-1"/>
           <p:cNvSpPr txBox="1"/>
           <p:nvPr/>
         </p:nvSpPr>
         <p:spPr>
           <a:xfrm>
-            <a:off x="1699321" y="3313176"/>
-            <a:ext cx="9255191" cy="780288"/>
+            <a:off x="1133856" y="3283428"/>
+            <a:ext cx="9820656" cy="839785"/>
           </a:xfrm>
           <a:prstGeom prst="rect">
             <a:avLst/>
@@ -36363,71 +34867,14 @@
       </p:sp>
       <p:sp>
         <p:nvSpPr>
-          <p:cNvPr id="54" name="Shape 47"/>
-          <p:cNvSpPr/>
-          <p:nvPr/>
-        </p:nvSpPr>
-        <p:spPr>
-          <a:xfrm>
-            <a:off x="1097280" y="4783044"/>
-            <a:ext cx="474025" cy="474025"/>
-          </a:xfrm>
-          <a:prstGeom prst="roundRect">
-            <a:avLst>
-              <a:gd name="adj" fmla="val 7716"/>
-            </a:avLst>
-          </a:prstGeom>
-          <a:solidFill>
-            <a:srgbClr val="F8FAFC"/>
-          </a:solidFill>
-          <a:ln w="12700">
-            <a:solidFill>
-              <a:srgbClr val="CBD5E1"/>
-            </a:solidFill>
-            <a:prstDash val="solid"/>
-          </a:ln>
-        </p:spPr>
-      </p:sp>
-      <p:pic>
-        <p:nvPicPr>
-          <p:cNvPr id="55" name="Image 5" descr="article icon from tabler-icons (MIT)">    </p:cNvPr>
-          <p:cNvPicPr>
-            <a:picLocks noChangeAspect="1"/>
-          </p:cNvPicPr>
-          <p:nvPr/>
-        </p:nvPicPr>
-        <p:blipFill>
-          <a:blip r:embed="rId11">
-            <a:extLst>
-              <a:ext uri="{96DAC541-7B7A-43D3-8B79-37D633B846F1}">
-                <asvg:svgBlip xmlns:asvg="http://schemas.microsoft.com/office/drawing/2016/SVG/main" r:embed="rId12"/>
-              </a:ext>
-            </a:extLst>
-          </a:blip>
-          <a:stretch>
-            <a:fillRect/>
-          </a:stretch>
-        </p:blipFill>
-        <p:spPr>
-          <a:xfrm>
-            <a:off x="1170432" y="4856196"/>
-            <a:ext cx="327721" cy="327721"/>
-          </a:xfrm>
-          <a:prstGeom prst="rect">
-            <a:avLst/>
-          </a:prstGeom>
-        </p:spPr>
-      </p:pic>
-      <p:sp>
-        <p:nvSpPr>
-          <p:cNvPr id="56" name="mdpr:1-2-32ac08:item-3:block-6-chunk-1"/>
+          <p:cNvPr id="50" name="mdpr:1-2-32ac08:item-3:block-6-chunk-1"/>
           <p:cNvSpPr txBox="1"/>
           <p:nvPr/>
         </p:nvSpPr>
         <p:spPr>
           <a:xfrm>
-            <a:off x="1699321" y="4629912"/>
-            <a:ext cx="9255191" cy="780288"/>
+            <a:off x="1133856" y="4600164"/>
+            <a:ext cx="9820656" cy="839785"/>
           </a:xfrm>
           <a:prstGeom prst="rect">
             <a:avLst/>
@@ -38897,71 +37344,14 @@
       </p:sp>
       <p:sp>
         <p:nvSpPr>
-          <p:cNvPr id="48" name="Shape 43"/>
-          <p:cNvSpPr/>
-          <p:nvPr/>
-        </p:nvSpPr>
-        <p:spPr>
-          <a:xfrm>
-            <a:off x="1097280" y="2140428"/>
-            <a:ext cx="474025" cy="474025"/>
-          </a:xfrm>
-          <a:prstGeom prst="roundRect">
-            <a:avLst>
-              <a:gd name="adj" fmla="val 7716"/>
-            </a:avLst>
-          </a:prstGeom>
-          <a:solidFill>
-            <a:srgbClr val="F8FAFC"/>
-          </a:solidFill>
-          <a:ln w="12700">
-            <a:solidFill>
-              <a:srgbClr val="CBD5E1"/>
-            </a:solidFill>
-            <a:prstDash val="solid"/>
-          </a:ln>
-        </p:spPr>
-      </p:sp>
-      <p:pic>
-        <p:nvPicPr>
-          <p:cNvPr id="49" name="Image 3" descr="article icon from tabler-icons (MIT)">    </p:cNvPr>
-          <p:cNvPicPr>
-            <a:picLocks noChangeAspect="1"/>
-          </p:cNvPicPr>
-          <p:nvPr/>
-        </p:nvPicPr>
-        <p:blipFill>
-          <a:blip r:embed="rId7">
-            <a:extLst>
-              <a:ext uri="{96DAC541-7B7A-43D3-8B79-37D633B846F1}">
-                <asvg:svgBlip xmlns:asvg="http://schemas.microsoft.com/office/drawing/2016/SVG/main" r:embed="rId8"/>
-              </a:ext>
-            </a:extLst>
-          </a:blip>
-          <a:stretch>
-            <a:fillRect/>
-          </a:stretch>
-        </p:blipFill>
-        <p:spPr>
-          <a:xfrm>
-            <a:off x="1170432" y="2213580"/>
-            <a:ext cx="327721" cy="327721"/>
-          </a:xfrm>
-          <a:prstGeom prst="rect">
-            <a:avLst/>
-          </a:prstGeom>
-        </p:spPr>
-      </p:pic>
-      <p:sp>
-        <p:nvSpPr>
-          <p:cNvPr id="50" name="mdpr:1-2-dfa474:item-1:block-8-chunk-1"/>
+          <p:cNvPr id="48" name="mdpr:1-2-dfa474:item-1:block-8-chunk-1"/>
           <p:cNvSpPr txBox="1"/>
           <p:nvPr/>
         </p:nvSpPr>
         <p:spPr>
           <a:xfrm>
-            <a:off x="1699321" y="1987296"/>
-            <a:ext cx="9255191" cy="780288"/>
+            <a:off x="1133856" y="1957548"/>
+            <a:ext cx="9820656" cy="839785"/>
           </a:xfrm>
           <a:prstGeom prst="rect">
             <a:avLst/>
@@ -39013,71 +37403,14 @@
       </p:sp>
       <p:sp>
         <p:nvSpPr>
-          <p:cNvPr id="51" name="Shape 45"/>
-          <p:cNvSpPr/>
-          <p:nvPr/>
-        </p:nvSpPr>
-        <p:spPr>
-          <a:xfrm>
-            <a:off x="1097280" y="3466308"/>
-            <a:ext cx="474025" cy="474025"/>
-          </a:xfrm>
-          <a:prstGeom prst="roundRect">
-            <a:avLst>
-              <a:gd name="adj" fmla="val 7716"/>
-            </a:avLst>
-          </a:prstGeom>
-          <a:solidFill>
-            <a:srgbClr val="F8FAFC"/>
-          </a:solidFill>
-          <a:ln w="12700">
-            <a:solidFill>
-              <a:srgbClr val="CBD5E1"/>
-            </a:solidFill>
-            <a:prstDash val="solid"/>
-          </a:ln>
-        </p:spPr>
-      </p:sp>
-      <p:pic>
-        <p:nvPicPr>
-          <p:cNvPr id="52" name="Image 4" descr="article icon from tabler-icons (MIT)">    </p:cNvPr>
-          <p:cNvPicPr>
-            <a:picLocks noChangeAspect="1"/>
-          </p:cNvPicPr>
-          <p:nvPr/>
-        </p:nvPicPr>
-        <p:blipFill>
-          <a:blip r:embed="rId9">
-            <a:extLst>
-              <a:ext uri="{96DAC541-7B7A-43D3-8B79-37D633B846F1}">
-                <asvg:svgBlip xmlns:asvg="http://schemas.microsoft.com/office/drawing/2016/SVG/main" r:embed="rId10"/>
-              </a:ext>
-            </a:extLst>
-          </a:blip>
-          <a:stretch>
-            <a:fillRect/>
-          </a:stretch>
-        </p:blipFill>
-        <p:spPr>
-          <a:xfrm>
-            <a:off x="1170432" y="3539460"/>
-            <a:ext cx="327721" cy="327721"/>
-          </a:xfrm>
-          <a:prstGeom prst="rect">
-            <a:avLst/>
-          </a:prstGeom>
-        </p:spPr>
-      </p:pic>
-      <p:sp>
-        <p:nvSpPr>
-          <p:cNvPr id="53" name="mdpr:1-2-dfa474:item-2:block-8-chunk-1"/>
+          <p:cNvPr id="49" name="mdpr:1-2-dfa474:item-2:block-8-chunk-1"/>
           <p:cNvSpPr txBox="1"/>
           <p:nvPr/>
         </p:nvSpPr>
         <p:spPr>
           <a:xfrm>
-            <a:off x="1699321" y="3313176"/>
-            <a:ext cx="9255191" cy="780288"/>
+            <a:off x="1133856" y="3283428"/>
+            <a:ext cx="9820656" cy="839785"/>
           </a:xfrm>
           <a:prstGeom prst="rect">
             <a:avLst/>
@@ -39129,71 +37462,14 @@
       </p:sp>
       <p:sp>
         <p:nvSpPr>
-          <p:cNvPr id="54" name="Shape 47"/>
-          <p:cNvSpPr/>
-          <p:nvPr/>
-        </p:nvSpPr>
-        <p:spPr>
-          <a:xfrm>
-            <a:off x="1097280" y="4783044"/>
-            <a:ext cx="474025" cy="474025"/>
-          </a:xfrm>
-          <a:prstGeom prst="roundRect">
-            <a:avLst>
-              <a:gd name="adj" fmla="val 7716"/>
-            </a:avLst>
-          </a:prstGeom>
-          <a:solidFill>
-            <a:srgbClr val="F8FAFC"/>
-          </a:solidFill>
-          <a:ln w="12700">
-            <a:solidFill>
-              <a:srgbClr val="CBD5E1"/>
-            </a:solidFill>
-            <a:prstDash val="solid"/>
-          </a:ln>
-        </p:spPr>
-      </p:sp>
-      <p:pic>
-        <p:nvPicPr>
-          <p:cNvPr id="55" name="Image 5" descr="article icon from tabler-icons (MIT)">    </p:cNvPr>
-          <p:cNvPicPr>
-            <a:picLocks noChangeAspect="1"/>
-          </p:cNvPicPr>
-          <p:nvPr/>
-        </p:nvPicPr>
-        <p:blipFill>
-          <a:blip r:embed="rId11">
-            <a:extLst>
-              <a:ext uri="{96DAC541-7B7A-43D3-8B79-37D633B846F1}">
-                <asvg:svgBlip xmlns:asvg="http://schemas.microsoft.com/office/drawing/2016/SVG/main" r:embed="rId12"/>
-              </a:ext>
-            </a:extLst>
-          </a:blip>
-          <a:stretch>
-            <a:fillRect/>
-          </a:stretch>
-        </p:blipFill>
-        <p:spPr>
-          <a:xfrm>
-            <a:off x="1170432" y="4856196"/>
-            <a:ext cx="327721" cy="327721"/>
-          </a:xfrm>
-          <a:prstGeom prst="rect">
-            <a:avLst/>
-          </a:prstGeom>
-        </p:spPr>
-      </p:pic>
-      <p:sp>
-        <p:nvSpPr>
-          <p:cNvPr id="56" name="mdpr:1-2-dfa474:item-3:block-8-chunk-1"/>
+          <p:cNvPr id="50" name="mdpr:1-2-dfa474:item-3:block-8-chunk-1"/>
           <p:cNvSpPr txBox="1"/>
           <p:nvPr/>
         </p:nvSpPr>
         <p:spPr>
           <a:xfrm>
-            <a:off x="1699321" y="4629912"/>
-            <a:ext cx="9255191" cy="780288"/>
+            <a:off x="1133856" y="4600164"/>
+            <a:ext cx="9820656" cy="839785"/>
           </a:xfrm>
           <a:prstGeom prst="rect">
             <a:avLst/>

</xml_diff>